<commit_message>
Tidy up docs and project metadata
</commit_message>
<xml_diff>
--- a/report/demo_slides.pptx
+++ b/report/demo_slides.pptx
@@ -1815,7 +1815,7 @@
                 <a:ea typeface="Calibri" pitchFamily="34" charset="-122"/>
                 <a:cs typeface="Calibri" pitchFamily="34" charset="-120"/>
               </a:rPr>
-              <a:t>Daoyuan Chi   ·   CS 131, Spring 2026</a:t>
+              <a:t>Daoyuan Chi   ·   Stanford University</a:t>
             </a:r>
             <a:endParaRPr lang="en-US" sz="1400" dirty="0"/>
           </a:p>
@@ -2076,7 +2076,7 @@
                 <a:ea typeface="Calibri" pitchFamily="34" charset="-122"/>
                 <a:cs typeface="Calibri" pitchFamily="34" charset="-120"/>
               </a:rPr>
-              <a:t>CS 131 Final Project  ·  Daoyuan Chi</a:t>
+              <a:t>Real-Time Perspective Correction  ·  Daoyuan Chi</a:t>
             </a:r>
             <a:endParaRPr lang="en-US" sz="900" dirty="0"/>
           </a:p>
@@ -2576,7 +2576,7 @@
                 <a:ea typeface="Calibri" pitchFamily="34" charset="-122"/>
                 <a:cs typeface="Calibri" pitchFamily="34" charset="-120"/>
               </a:rPr>
-              <a:t>CS 131 Final Project  ·  Daoyuan Chi</a:t>
+              <a:t>Real-Time Perspective Correction  ·  Daoyuan Chi</a:t>
             </a:r>
             <a:endParaRPr lang="en-US" sz="900" dirty="0"/>
           </a:p>
@@ -2896,7 +2896,7 @@
                 <a:ea typeface="Calibri" pitchFamily="34" charset="-122"/>
                 <a:cs typeface="Calibri" pitchFamily="34" charset="-120"/>
               </a:rPr>
-              <a:t>CS 131 Final Project  ·  Daoyuan Chi</a:t>
+              <a:t>Real-Time Perspective Correction  ·  Daoyuan Chi</a:t>
             </a:r>
             <a:endParaRPr lang="en-US" sz="900" dirty="0"/>
           </a:p>
@@ -3186,7 +3186,7 @@
                 <a:ea typeface="Calibri" pitchFamily="34" charset="-122"/>
                 <a:cs typeface="Calibri" pitchFamily="34" charset="-120"/>
               </a:rPr>
-              <a:t>CS 131 Final Project  ·  Daoyuan Chi</a:t>
+              <a:t>Real-Time Perspective Correction  ·  Daoyuan Chi</a:t>
             </a:r>
             <a:endParaRPr lang="en-US" sz="900" dirty="0"/>
           </a:p>
@@ -3530,7 +3530,7 @@
                 <a:ea typeface="Calibri" pitchFamily="34" charset="-122"/>
                 <a:cs typeface="Calibri" pitchFamily="34" charset="-120"/>
               </a:rPr>
-              <a:t>CS 131 Final Project  ·  Daoyuan Chi</a:t>
+              <a:t>Real-Time Perspective Correction  ·  Daoyuan Chi</a:t>
             </a:r>
             <a:endParaRPr lang="en-US" sz="900" dirty="0"/>
           </a:p>
@@ -3821,7 +3821,7 @@
                 <a:ea typeface="Calibri" pitchFamily="34" charset="-122"/>
                 <a:cs typeface="Calibri" pitchFamily="34" charset="-120"/>
               </a:rPr>
-              <a:t>github.com/Danni281/cs-131-final-project   ·   Thank you</a:t>
+              <a:t>github.com/Danni281/selfie-perspective-correction   ·   Thank you</a:t>
             </a:r>
             <a:endParaRPr lang="en-US" sz="1300" dirty="0"/>
           </a:p>

</xml_diff>